<commit_message>
feat: unificar slides 1 con título y lede consistentes; regenerar PDFs y PPTX
</commit_message>
<xml_diff>
--- a/presentaciones-html/clase-1/clase-1.pptx
+++ b/presentaciones-html/clase-1/clase-1.pptx
@@ -6136,7 +6136,7 @@
                 </a:solidFill>
                 <a:latin typeface="Calibri"/>
               </a:rPr>
-              <a:t>Presentación de la Materia</a:t>
+              <a:t>Ingeniería de Software I</a:t>
             </a:r>
           </a:p>
         </p:txBody>
@@ -6206,7 +6206,7 @@
                 </a:solidFill>
                 <a:latin typeface="Calibri"/>
               </a:rPr>
-              <a:t>INGENIERÍA DE SOFTWARE I</a:t>
+              <a:t>PRESENTACIÓN DE LA MATERIA</a:t>
             </a:r>
           </a:p>
         </p:txBody>
@@ -6220,41 +6220,6 @@
         <p:spPr>
           <a:xfrm>
             <a:off x="502920" y="2651760"/>
-            <a:ext cx="11155680" cy="457200"/>
-          </a:xfrm>
-          <a:prstGeom prst="rect">
-            <a:avLst/>
-          </a:prstGeom>
-          <a:noFill/>
-        </p:spPr>
-        <p:txBody>
-          <a:bodyPr wrap="square" anchor="t" lIns="0" rIns="0" tIns="0" bIns="0">
-            <a:spAutoFit/>
-          </a:bodyPr>
-          <a:lstStyle/>
-          <a:p>
-            <a:pPr algn="l"/>
-            <a:r>
-              <a:rPr sz="1900" b="1" i="0">
-                <a:solidFill>
-                  <a:srgbClr val="2C4A8A"/>
-                </a:solidFill>
-                <a:latin typeface="Calibri"/>
-              </a:rPr>
-              <a:t>PRESENTACIÓN DE LA MATERIA</a:t>
-            </a:r>
-          </a:p>
-        </p:txBody>
-      </p:sp>
-      <p:sp>
-        <p:nvSpPr>
-          <p:cNvPr id="11" name="TextBox 10"/>
-          <p:cNvSpPr txBox="1"/>
-          <p:nvPr/>
-        </p:nvSpPr>
-        <p:spPr>
-          <a:xfrm>
-            <a:off x="502920" y="3163824"/>
             <a:ext cx="11155680" cy="347472"/>
           </a:xfrm>
           <a:prstGeom prst="rect">
@@ -6587,41 +6552,6 @@
         <p:spPr>
           <a:xfrm>
             <a:off x="502920" y="2651760"/>
-            <a:ext cx="11155680" cy="457200"/>
-          </a:xfrm>
-          <a:prstGeom prst="rect">
-            <a:avLst/>
-          </a:prstGeom>
-          <a:noFill/>
-        </p:spPr>
-        <p:txBody>
-          <a:bodyPr wrap="square" anchor="t" lIns="0" rIns="0" tIns="0" bIns="0">
-            <a:spAutoFit/>
-          </a:bodyPr>
-          <a:lstStyle/>
-          <a:p>
-            <a:pPr algn="l"/>
-            <a:r>
-              <a:rPr sz="1900" b="1" i="0">
-                <a:solidFill>
-                  <a:srgbClr val="2C4A8A"/>
-                </a:solidFill>
-                <a:latin typeface="Calibri"/>
-              </a:rPr>
-              <a:t>UNIDAD I – INTRODUCCIÓN A LA INGENIERÍA DE SOFTWARE</a:t>
-            </a:r>
-          </a:p>
-        </p:txBody>
-      </p:sp>
-      <p:sp>
-        <p:nvSpPr>
-          <p:cNvPr id="11" name="TextBox 10"/>
-          <p:cNvSpPr txBox="1"/>
-          <p:nvPr/>
-        </p:nvSpPr>
-        <p:spPr>
-          <a:xfrm>
-            <a:off x="502920" y="3163824"/>
             <a:ext cx="11155680" cy="347472"/>
           </a:xfrm>
           <a:prstGeom prst="rect">
@@ -8000,48 +7930,13 @@
       </p:sp>
       <p:sp>
         <p:nvSpPr>
-          <p:cNvPr id="10" name="TextBox 9"/>
-          <p:cNvSpPr txBox="1"/>
+          <p:cNvPr id="10" name="Rounded Rectangle 9"/>
+          <p:cNvSpPr/>
           <p:nvPr/>
         </p:nvSpPr>
         <p:spPr>
           <a:xfrm>
             <a:off x="502920" y="3337560"/>
-            <a:ext cx="11155680" cy="292608"/>
-          </a:xfrm>
-          <a:prstGeom prst="rect">
-            <a:avLst/>
-          </a:prstGeom>
-          <a:noFill/>
-        </p:spPr>
-        <p:txBody>
-          <a:bodyPr wrap="square" anchor="t" lIns="0" rIns="0" tIns="0" bIns="0">
-            <a:spAutoFit/>
-          </a:bodyPr>
-          <a:lstStyle/>
-          <a:p>
-            <a:pPr algn="l"/>
-            <a:r>
-              <a:rPr sz="1100" b="0" i="1">
-                <a:solidFill>
-                  <a:srgbClr val="4A556B"/>
-                </a:solidFill>
-                <a:latin typeface="Calibri"/>
-              </a:rPr>
-              <a:t>📚 Sommerville, I. Ingeniería de Software, 7ª ed. Addison Wesley, 2005.</a:t>
-            </a:r>
-          </a:p>
-        </p:txBody>
-      </p:sp>
-      <p:sp>
-        <p:nvSpPr>
-          <p:cNvPr id="11" name="Rounded Rectangle 10"/>
-          <p:cNvSpPr/>
-          <p:nvPr/>
-        </p:nvSpPr>
-        <p:spPr>
-          <a:xfrm>
-            <a:off x="502920" y="3666744"/>
             <a:ext cx="3505200" cy="1517904"/>
           </a:xfrm>
           <a:prstGeom prst="roundRect">
@@ -8083,48 +7978,48 @@
       </p:sp>
       <p:sp>
         <p:nvSpPr>
+          <p:cNvPr id="11" name="TextBox 10"/>
+          <p:cNvSpPr txBox="1"/>
+          <p:nvPr/>
+        </p:nvSpPr>
+        <p:spPr>
+          <a:xfrm>
+            <a:off x="685800" y="3447288"/>
+            <a:ext cx="3139440" cy="274320"/>
+          </a:xfrm>
+          <a:prstGeom prst="rect">
+            <a:avLst/>
+          </a:prstGeom>
+          <a:noFill/>
+        </p:spPr>
+        <p:txBody>
+          <a:bodyPr wrap="square" anchor="t" lIns="0" rIns="0" tIns="0" bIns="0">
+            <a:spAutoFit/>
+          </a:bodyPr>
+          <a:lstStyle/>
+          <a:p>
+            <a:pPr algn="l"/>
+            <a:r>
+              <a:rPr sz="1500" b="1" i="0">
+                <a:solidFill>
+                  <a:srgbClr val="2C4A8A"/>
+                </a:solidFill>
+                <a:latin typeface="Calibri"/>
+              </a:rPr>
+              <a:t>Disciplina</a:t>
+            </a:r>
+          </a:p>
+        </p:txBody>
+      </p:sp>
+      <p:sp>
+        <p:nvSpPr>
           <p:cNvPr id="12" name="TextBox 11"/>
           <p:cNvSpPr txBox="1"/>
           <p:nvPr/>
         </p:nvSpPr>
         <p:spPr>
           <a:xfrm>
-            <a:off x="685800" y="3776472"/>
-            <a:ext cx="3139440" cy="274320"/>
-          </a:xfrm>
-          <a:prstGeom prst="rect">
-            <a:avLst/>
-          </a:prstGeom>
-          <a:noFill/>
-        </p:spPr>
-        <p:txBody>
-          <a:bodyPr wrap="square" anchor="t" lIns="0" rIns="0" tIns="0" bIns="0">
-            <a:spAutoFit/>
-          </a:bodyPr>
-          <a:lstStyle/>
-          <a:p>
-            <a:pPr algn="l"/>
-            <a:r>
-              <a:rPr sz="1500" b="1" i="0">
-                <a:solidFill>
-                  <a:srgbClr val="2C4A8A"/>
-                </a:solidFill>
-                <a:latin typeface="Calibri"/>
-              </a:rPr>
-              <a:t>Disciplina</a:t>
-            </a:r>
-          </a:p>
-        </p:txBody>
-      </p:sp>
-      <p:sp>
-        <p:nvSpPr>
-          <p:cNvPr id="13" name="TextBox 12"/>
-          <p:cNvSpPr txBox="1"/>
-          <p:nvPr/>
-        </p:nvSpPr>
-        <p:spPr>
-          <a:xfrm>
-            <a:off x="685800" y="4050791"/>
+            <a:off x="685800" y="3721608"/>
             <a:ext cx="3139440" cy="877824"/>
           </a:xfrm>
           <a:prstGeom prst="rect">
@@ -8153,13 +8048,13 @@
       </p:sp>
       <p:sp>
         <p:nvSpPr>
-          <p:cNvPr id="14" name="Rounded Rectangle 13"/>
+          <p:cNvPr id="13" name="Rounded Rectangle 12"/>
           <p:cNvSpPr/>
           <p:nvPr/>
         </p:nvSpPr>
         <p:spPr>
           <a:xfrm>
-            <a:off x="4328160" y="3666744"/>
+            <a:off x="4328160" y="3337560"/>
             <a:ext cx="3505200" cy="1719072"/>
           </a:xfrm>
           <a:prstGeom prst="roundRect">
@@ -8201,48 +8096,48 @@
       </p:sp>
       <p:sp>
         <p:nvSpPr>
+          <p:cNvPr id="14" name="TextBox 13"/>
+          <p:cNvSpPr txBox="1"/>
+          <p:nvPr/>
+        </p:nvSpPr>
+        <p:spPr>
+          <a:xfrm>
+            <a:off x="4511040" y="3447288"/>
+            <a:ext cx="3139440" cy="274320"/>
+          </a:xfrm>
+          <a:prstGeom prst="rect">
+            <a:avLst/>
+          </a:prstGeom>
+          <a:noFill/>
+        </p:spPr>
+        <p:txBody>
+          <a:bodyPr wrap="square" anchor="t" lIns="0" rIns="0" tIns="0" bIns="0">
+            <a:spAutoFit/>
+          </a:bodyPr>
+          <a:lstStyle/>
+          <a:p>
+            <a:pPr algn="l"/>
+            <a:r>
+              <a:rPr sz="1500" b="1" i="0">
+                <a:solidFill>
+                  <a:srgbClr val="2C4A8A"/>
+                </a:solidFill>
+                <a:latin typeface="Calibri"/>
+              </a:rPr>
+              <a:t>Principios</a:t>
+            </a:r>
+          </a:p>
+        </p:txBody>
+      </p:sp>
+      <p:sp>
+        <p:nvSpPr>
           <p:cNvPr id="15" name="TextBox 14"/>
           <p:cNvSpPr txBox="1"/>
           <p:nvPr/>
         </p:nvSpPr>
         <p:spPr>
           <a:xfrm>
-            <a:off x="4511040" y="3776472"/>
-            <a:ext cx="3139440" cy="274320"/>
-          </a:xfrm>
-          <a:prstGeom prst="rect">
-            <a:avLst/>
-          </a:prstGeom>
-          <a:noFill/>
-        </p:spPr>
-        <p:txBody>
-          <a:bodyPr wrap="square" anchor="t" lIns="0" rIns="0" tIns="0" bIns="0">
-            <a:spAutoFit/>
-          </a:bodyPr>
-          <a:lstStyle/>
-          <a:p>
-            <a:pPr algn="l"/>
-            <a:r>
-              <a:rPr sz="1500" b="1" i="0">
-                <a:solidFill>
-                  <a:srgbClr val="2C4A8A"/>
-                </a:solidFill>
-                <a:latin typeface="Calibri"/>
-              </a:rPr>
-              <a:t>Principios</a:t>
-            </a:r>
-          </a:p>
-        </p:txBody>
-      </p:sp>
-      <p:sp>
-        <p:nvSpPr>
-          <p:cNvPr id="16" name="TextBox 15"/>
-          <p:cNvSpPr txBox="1"/>
-          <p:nvPr/>
-        </p:nvSpPr>
-        <p:spPr>
-          <a:xfrm>
-            <a:off x="4511040" y="4050791"/>
+            <a:off x="4511040" y="3721608"/>
             <a:ext cx="3139440" cy="1078992"/>
           </a:xfrm>
           <a:prstGeom prst="rect">
@@ -8271,13 +8166,13 @@
       </p:sp>
       <p:sp>
         <p:nvSpPr>
-          <p:cNvPr id="17" name="Rounded Rectangle 16"/>
+          <p:cNvPr id="16" name="Rounded Rectangle 15"/>
           <p:cNvSpPr/>
           <p:nvPr/>
         </p:nvSpPr>
         <p:spPr>
           <a:xfrm>
-            <a:off x="8153400" y="3666744"/>
+            <a:off x="8153400" y="3337560"/>
             <a:ext cx="3505200" cy="1719072"/>
           </a:xfrm>
           <a:prstGeom prst="roundRect">
@@ -8319,35 +8214,70 @@
       </p:sp>
       <p:sp>
         <p:nvSpPr>
+          <p:cNvPr id="17" name="TextBox 16"/>
+          <p:cNvSpPr txBox="1"/>
+          <p:nvPr/>
+        </p:nvSpPr>
+        <p:spPr>
+          <a:xfrm>
+            <a:off x="8336280" y="3447288"/>
+            <a:ext cx="3139440" cy="274320"/>
+          </a:xfrm>
+          <a:prstGeom prst="rect">
+            <a:avLst/>
+          </a:prstGeom>
+          <a:noFill/>
+        </p:spPr>
+        <p:txBody>
+          <a:bodyPr wrap="square" anchor="t" lIns="0" rIns="0" tIns="0" bIns="0">
+            <a:spAutoFit/>
+          </a:bodyPr>
+          <a:lstStyle/>
+          <a:p>
+            <a:pPr algn="l"/>
+            <a:r>
+              <a:rPr sz="1500" b="1" i="0">
+                <a:solidFill>
+                  <a:srgbClr val="2C4A8A"/>
+                </a:solidFill>
+                <a:latin typeface="Calibri"/>
+              </a:rPr>
+              <a:t>Métodos</a:t>
+            </a:r>
+          </a:p>
+        </p:txBody>
+      </p:sp>
+      <p:sp>
+        <p:nvSpPr>
           <p:cNvPr id="18" name="TextBox 17"/>
           <p:cNvSpPr txBox="1"/>
           <p:nvPr/>
         </p:nvSpPr>
         <p:spPr>
           <a:xfrm>
-            <a:off x="8336280" y="3776472"/>
-            <a:ext cx="3139440" cy="274320"/>
-          </a:xfrm>
-          <a:prstGeom prst="rect">
-            <a:avLst/>
-          </a:prstGeom>
-          <a:noFill/>
-        </p:spPr>
-        <p:txBody>
-          <a:bodyPr wrap="square" anchor="t" lIns="0" rIns="0" tIns="0" bIns="0">
-            <a:spAutoFit/>
-          </a:bodyPr>
-          <a:lstStyle/>
-          <a:p>
-            <a:pPr algn="l"/>
-            <a:r>
-              <a:rPr sz="1500" b="1" i="0">
-                <a:solidFill>
-                  <a:srgbClr val="2C4A8A"/>
-                </a:solidFill>
-                <a:latin typeface="Calibri"/>
-              </a:rPr>
-              <a:t>Métodos</a:t>
+            <a:off x="8336280" y="3721608"/>
+            <a:ext cx="3139440" cy="1078992"/>
+          </a:xfrm>
+          <a:prstGeom prst="rect">
+            <a:avLst/>
+          </a:prstGeom>
+          <a:noFill/>
+        </p:spPr>
+        <p:txBody>
+          <a:bodyPr wrap="square" anchor="t" lIns="0" rIns="0" tIns="0" bIns="0">
+            <a:spAutoFit/>
+          </a:bodyPr>
+          <a:lstStyle/>
+          <a:p>
+            <a:pPr algn="l"/>
+            <a:r>
+              <a:rPr sz="1300" b="0" i="0">
+                <a:solidFill>
+                  <a:srgbClr val="1F2937"/>
+                </a:solidFill>
+                <a:latin typeface="Calibri"/>
+              </a:rPr>
+              <a:t>Establecimiento y uso de métodos, herramientas y procedimientos, orientados a obtener software económico que sea fiable y funcione de manera eficiente.</a:t>
             </a:r>
           </a:p>
         </p:txBody>
@@ -8360,29 +8290,29 @@
         </p:nvSpPr>
         <p:spPr>
           <a:xfrm>
-            <a:off x="8336280" y="4050791"/>
-            <a:ext cx="3139440" cy="1078992"/>
-          </a:xfrm>
-          <a:prstGeom prst="rect">
-            <a:avLst/>
-          </a:prstGeom>
-          <a:noFill/>
-        </p:spPr>
-        <p:txBody>
-          <a:bodyPr wrap="square" anchor="t" lIns="0" rIns="0" tIns="0" bIns="0">
-            <a:spAutoFit/>
-          </a:bodyPr>
-          <a:lstStyle/>
-          <a:p>
-            <a:pPr algn="l"/>
-            <a:r>
-              <a:rPr sz="1300" b="0" i="0">
-                <a:solidFill>
-                  <a:srgbClr val="1F2937"/>
-                </a:solidFill>
-                <a:latin typeface="Calibri"/>
-              </a:rPr>
-              <a:t>Establecimiento y uso de métodos, herramientas y procedimientos, orientados a obtener software económico que sea fiable y funcione de manera eficiente.</a:t>
+            <a:off x="502920" y="5056632"/>
+            <a:ext cx="11155680" cy="292608"/>
+          </a:xfrm>
+          <a:prstGeom prst="rect">
+            <a:avLst/>
+          </a:prstGeom>
+          <a:noFill/>
+        </p:spPr>
+        <p:txBody>
+          <a:bodyPr wrap="square" anchor="t" lIns="0" rIns="0" tIns="0" bIns="0">
+            <a:spAutoFit/>
+          </a:bodyPr>
+          <a:lstStyle/>
+          <a:p>
+            <a:pPr algn="l"/>
+            <a:r>
+              <a:rPr sz="1100" b="0" i="1">
+                <a:solidFill>
+                  <a:srgbClr val="4A556B"/>
+                </a:solidFill>
+                <a:latin typeface="Calibri"/>
+              </a:rPr>
+              <a:t>📚 Sommerville, I. Ingeniería de Software, 7ª ed. Addison Wesley, 2005.</a:t>
             </a:r>
           </a:p>
         </p:txBody>

</xml_diff>